<commit_message>
Réglage de petit soucis dans le chargement et le zoom
</commit_message>
<xml_diff>
--- a/presentation_stage_m2_soitel_remi.pptx
+++ b/presentation_stage_m2_soitel_remi.pptx
@@ -5,21 +5,22 @@
     <p:sldMasterId id="2147483708" r:id="rId4"/>
   </p:sldMasterIdLst>
   <p:notesMasterIdLst>
-    <p:notesMasterId r:id="rId14"/>
+    <p:notesMasterId r:id="rId15"/>
   </p:notesMasterIdLst>
   <p:handoutMasterIdLst>
-    <p:handoutMasterId r:id="rId15"/>
+    <p:handoutMasterId r:id="rId16"/>
   </p:handoutMasterIdLst>
   <p:sldIdLst>
     <p:sldId id="256" r:id="rId5"/>
     <p:sldId id="310" r:id="rId6"/>
     <p:sldId id="290" r:id="rId7"/>
     <p:sldId id="378" r:id="rId8"/>
-    <p:sldId id="376" r:id="rId9"/>
-    <p:sldId id="325" r:id="rId10"/>
-    <p:sldId id="377" r:id="rId11"/>
-    <p:sldId id="328" r:id="rId12"/>
-    <p:sldId id="274" r:id="rId13"/>
+    <p:sldId id="379" r:id="rId9"/>
+    <p:sldId id="376" r:id="rId10"/>
+    <p:sldId id="325" r:id="rId11"/>
+    <p:sldId id="377" r:id="rId12"/>
+    <p:sldId id="328" r:id="rId13"/>
+    <p:sldId id="274" r:id="rId14"/>
   </p:sldIdLst>
   <p:sldSz cx="12192000" cy="6858000"/>
   <p:notesSz cx="6858000" cy="9144000"/>
@@ -3808,7 +3809,7 @@
             <a:pPr rtl="0"/>
             <a:fld id="{E2DFA899-6BDB-45C9-946A-2F5DBB8DE804}" type="datetime1">
               <a:rPr lang="fr-FR" smtClean="0"/>
-              <a:t>19/05/2026</a:t>
+              <a:t>26/05/2026</a:t>
             </a:fld>
             <a:endParaRPr lang="fr-FR"/>
           </a:p>
@@ -3990,7 +3991,7 @@
             <a:fld id="{DD3D3324-EB6D-49CC-AD79-1ACDDDC10179}" type="datetime1">
               <a:rPr lang="fr-FR" smtClean="0"/>
               <a:pPr/>
-              <a:t>19/05/2026</a:t>
+              <a:t>26/05/2026</a:t>
             </a:fld>
             <a:endParaRPr lang="fr-FR" dirty="0"/>
           </a:p>
@@ -4600,7 +4601,7 @@
             <a:pPr rtl="0"/>
             <a:fld id="{96702109-9DB5-4930-9529-97D0F7F71D9D}" type="slidenum">
               <a:rPr lang="fr-FR" smtClean="0"/>
-              <a:t>5</a:t>
+              <a:t>6</a:t>
             </a:fld>
             <a:endParaRPr lang="fr-FR"/>
           </a:p>
@@ -4702,7 +4703,7 @@
             <a:pPr rtl="0"/>
             <a:fld id="{EE85D185-D876-4A4B-A351-E623992245C2}" type="slidenum">
               <a:rPr lang="fr-FR" smtClean="0"/>
-              <a:t>6</a:t>
+              <a:t>7</a:t>
             </a:fld>
             <a:endParaRPr lang="fr-FR"/>
           </a:p>
@@ -4787,7 +4788,7 @@
             <a:pPr rtl="0"/>
             <a:fld id="{96702109-9DB5-4930-9529-97D0F7F71D9D}" type="slidenum">
               <a:rPr lang="fr-FR" smtClean="0"/>
-              <a:t>7</a:t>
+              <a:t>8</a:t>
             </a:fld>
             <a:endParaRPr lang="fr-FR"/>
           </a:p>
@@ -4889,7 +4890,7 @@
             <a:pPr rtl="0"/>
             <a:fld id="{EE85D185-D876-4A4B-A351-E623992245C2}" type="slidenum">
               <a:rPr lang="fr-FR" smtClean="0"/>
-              <a:t>8</a:t>
+              <a:t>9</a:t>
             </a:fld>
             <a:endParaRPr lang="fr-FR"/>
           </a:p>
@@ -4991,7 +4992,7 @@
             <a:pPr rtl="0"/>
             <a:fld id="{EE85D185-D876-4A4B-A351-E623992245C2}" type="slidenum">
               <a:rPr lang="fr-FR" smtClean="0"/>
-              <a:t>9</a:t>
+              <a:t>10</a:t>
             </a:fld>
             <a:endParaRPr lang="fr-FR"/>
           </a:p>
@@ -27264,6 +27265,100 @@
 </p:sld>
 </file>
 
+<file path=ppt/slides/slide10.xml><?xml version="1.0" encoding="utf-8"?>
+<p:sld xmlns:a="http://schemas.openxmlformats.org/drawingml/2006/main" xmlns:r="http://schemas.openxmlformats.org/officeDocument/2006/relationships" xmlns:p="http://schemas.openxmlformats.org/presentationml/2006/main">
+  <p:cSld>
+    <p:spTree>
+      <p:nvGrpSpPr>
+        <p:cNvPr id="1" name=""/>
+        <p:cNvGrpSpPr/>
+        <p:nvPr/>
+      </p:nvGrpSpPr>
+      <p:grpSpPr>
+        <a:xfrm>
+          <a:off x="0" y="0"/>
+          <a:ext cx="0" cy="0"/>
+          <a:chOff x="0" y="0"/>
+          <a:chExt cx="0" cy="0"/>
+        </a:xfrm>
+      </p:grpSpPr>
+      <p:sp>
+        <p:nvSpPr>
+          <p:cNvPr id="54" name="Titre 53">
+            <a:extLst>
+              <a:ext uri="{FF2B5EF4-FFF2-40B4-BE49-F238E27FC236}">
+                <a16:creationId xmlns:a16="http://schemas.microsoft.com/office/drawing/2014/main" id="{DBE49DF2-C4C7-4EC0-BF95-00C033956ED5}"/>
+              </a:ext>
+            </a:extLst>
+          </p:cNvPr>
+          <p:cNvSpPr>
+            <a:spLocks noGrp="1"/>
+          </p:cNvSpPr>
+          <p:nvPr>
+            <p:ph type="title"/>
+          </p:nvPr>
+        </p:nvSpPr>
+        <p:spPr>
+          <a:xfrm>
+            <a:off x="531405" y="1643117"/>
+            <a:ext cx="5465225" cy="2637455"/>
+          </a:xfrm>
+        </p:spPr>
+        <p:txBody>
+          <a:bodyPr rtlCol="0"/>
+          <a:lstStyle/>
+          <a:p>
+            <a:pPr rtl="0"/>
+            <a:r>
+              <a:rPr lang="fr-FR" dirty="0"/>
+              <a:t>Merci de votre Attention</a:t>
+            </a:r>
+          </a:p>
+        </p:txBody>
+      </p:sp>
+      <p:pic>
+        <p:nvPicPr>
+          <p:cNvPr id="11" name="Image 10">
+            <a:extLst>
+              <a:ext uri="{FF2B5EF4-FFF2-40B4-BE49-F238E27FC236}">
+                <a16:creationId xmlns:a16="http://schemas.microsoft.com/office/drawing/2014/main" id="{C6CD20B5-B984-747C-4C89-72C2D1380677}"/>
+              </a:ext>
+            </a:extLst>
+          </p:cNvPr>
+          <p:cNvPicPr>
+            <a:picLocks noChangeAspect="1"/>
+          </p:cNvPicPr>
+          <p:nvPr/>
+        </p:nvPicPr>
+        <p:blipFill>
+          <a:blip r:embed="rId3"/>
+          <a:stretch>
+            <a:fillRect/>
+          </a:stretch>
+        </p:blipFill>
+        <p:spPr>
+          <a:xfrm>
+            <a:off x="5204315" y="72485"/>
+            <a:ext cx="6713029" cy="6713029"/>
+          </a:xfrm>
+          <a:prstGeom prst="rect">
+            <a:avLst/>
+          </a:prstGeom>
+        </p:spPr>
+      </p:pic>
+    </p:spTree>
+    <p:extLst>
+      <p:ext uri="{BB962C8B-B14F-4D97-AF65-F5344CB8AC3E}">
+        <p14:creationId xmlns:p14="http://schemas.microsoft.com/office/powerpoint/2010/main" val="1833651384"/>
+      </p:ext>
+    </p:extLst>
+  </p:cSld>
+  <p:clrMapOvr>
+    <a:masterClrMapping/>
+  </p:clrMapOvr>
+</p:sld>
+</file>
+
 <file path=ppt/slides/slide2.xml><?xml version="1.0" encoding="utf-8"?>
 <p:sld xmlns:a="http://schemas.openxmlformats.org/drawingml/2006/main" xmlns:r="http://schemas.openxmlformats.org/officeDocument/2006/relationships" xmlns:p="http://schemas.openxmlformats.org/presentationml/2006/main">
   <p:cSld>
@@ -27627,19 +27722,30 @@
         <p:spPr>
           <a:xfrm>
             <a:off x="552476" y="1915446"/>
-            <a:ext cx="8503034" cy="3358733"/>
+            <a:ext cx="11182324" cy="4217087"/>
           </a:xfrm>
         </p:spPr>
         <p:txBody>
           <a:bodyPr rtlCol="0">
-            <a:normAutofit/>
+            <a:noAutofit/>
           </a:bodyPr>
           <a:lstStyle/>
           <a:p>
-            <a:pPr rtl="0"/>
             <a:r>
-              <a:rPr lang="fr-FR" sz="2800" dirty="0"/>
-              <a:t>Ave</a:t>
+              <a:rPr lang="fr-FR" sz="2200" dirty="0"/>
+              <a:t>• Je tiens à remercier Monsieur Stéphane SOITEL, Président de Chauffage Der Energies et tuteur de stage, pour son encadrement, ses remarques et son soutien tout au long du stage.</a:t>
+            </a:r>
+          </a:p>
+          <a:p>
+            <a:r>
+              <a:rPr lang="fr-FR" sz="2200" dirty="0"/>
+              <a:t>• Merci également à Monsieur Hacène Fouchal, Responsable de formation du Master Informatique, pour l’opportunité d’effectuer ce stage et d'y appliquer nos connaissances.</a:t>
+            </a:r>
+          </a:p>
+          <a:p>
+            <a:r>
+              <a:rPr lang="fr-FR" sz="2200" dirty="0"/>
+              <a:t>• Enfin, merci à l’ensemble de l’équipe de Chauffage Der Energies pour leur accueil chaleureux et l'environnement de travail propice à l'apprentissage</a:t>
             </a:r>
           </a:p>
         </p:txBody>
@@ -27905,229 +28011,6 @@
       </p:sp>
       <p:sp>
         <p:nvSpPr>
-          <p:cNvPr id="9" name="Espace réservé du contenu 11">
-            <a:extLst>
-              <a:ext uri="{FF2B5EF4-FFF2-40B4-BE49-F238E27FC236}">
-                <a16:creationId xmlns:a16="http://schemas.microsoft.com/office/drawing/2014/main" id="{09CA1B99-EEA7-7FB3-9909-78D0D9454671}"/>
-              </a:ext>
-            </a:extLst>
-          </p:cNvPr>
-          <p:cNvSpPr txBox="1">
-            <a:spLocks/>
-          </p:cNvSpPr>
-          <p:nvPr/>
-        </p:nvSpPr>
-        <p:spPr>
-          <a:xfrm>
-            <a:off x="457200" y="1885949"/>
-            <a:ext cx="5543524" cy="3358733"/>
-          </a:xfrm>
-          <a:prstGeom prst="rect">
-            <a:avLst/>
-          </a:prstGeom>
-        </p:spPr>
-        <p:txBody>
-          <a:bodyPr rtlCol="0">
-            <a:normAutofit/>
-          </a:bodyPr>
-          <a:lstStyle>
-            <a:lvl1pPr marL="228600" indent="-228600" algn="l" defTabSz="914400" rtl="0" eaLnBrk="1" latinLnBrk="0" hangingPunct="1">
-              <a:lnSpc>
-                <a:spcPct val="110000"/>
-              </a:lnSpc>
-              <a:spcBef>
-                <a:spcPts val="1000"/>
-              </a:spcBef>
-              <a:buClr>
-                <a:schemeClr val="bg1"/>
-              </a:buClr>
-              <a:buSzPct val="75000"/>
-              <a:buFont typeface="+mj-lt"/>
-              <a:buAutoNum type="arabicPeriod"/>
-              <a:defRPr sz="2800" kern="1200">
-                <a:solidFill>
-                  <a:srgbClr val="FFFFFF"/>
-                </a:solidFill>
-                <a:latin typeface="+mn-lt"/>
-                <a:ea typeface="+mn-ea"/>
-                <a:cs typeface="+mn-cs"/>
-              </a:defRPr>
-            </a:lvl1pPr>
-            <a:lvl2pPr marL="228600" indent="-228600" algn="l" defTabSz="914400" rtl="0" eaLnBrk="1" latinLnBrk="0" hangingPunct="1">
-              <a:lnSpc>
-                <a:spcPct val="110000"/>
-              </a:lnSpc>
-              <a:spcBef>
-                <a:spcPts val="500"/>
-              </a:spcBef>
-              <a:buClr>
-                <a:schemeClr val="bg1"/>
-              </a:buClr>
-              <a:buSzPct val="75000"/>
-              <a:buFont typeface="+mj-lt"/>
-              <a:buAutoNum type="arabicPeriod"/>
-              <a:defRPr sz="2400" kern="1200">
-                <a:solidFill>
-                  <a:srgbClr val="FFFFFF"/>
-                </a:solidFill>
-                <a:latin typeface="+mn-lt"/>
-                <a:ea typeface="+mn-ea"/>
-                <a:cs typeface="+mn-cs"/>
-              </a:defRPr>
-            </a:lvl2pPr>
-            <a:lvl3pPr marL="228600" indent="-228600" algn="l" defTabSz="914400" rtl="0" eaLnBrk="1" latinLnBrk="0" hangingPunct="1">
-              <a:lnSpc>
-                <a:spcPct val="110000"/>
-              </a:lnSpc>
-              <a:spcBef>
-                <a:spcPts val="500"/>
-              </a:spcBef>
-              <a:buClr>
-                <a:schemeClr val="bg1"/>
-              </a:buClr>
-              <a:buSzPct val="75000"/>
-              <a:buFont typeface="+mj-lt"/>
-              <a:buAutoNum type="arabicPeriod"/>
-              <a:defRPr sz="2000" kern="1200">
-                <a:solidFill>
-                  <a:srgbClr val="FFFFFF"/>
-                </a:solidFill>
-                <a:latin typeface="+mn-lt"/>
-                <a:ea typeface="+mn-ea"/>
-                <a:cs typeface="+mn-cs"/>
-              </a:defRPr>
-            </a:lvl3pPr>
-            <a:lvl4pPr marL="228600" indent="-228600" algn="l" defTabSz="914400" rtl="0" eaLnBrk="1" latinLnBrk="0" hangingPunct="1">
-              <a:lnSpc>
-                <a:spcPct val="110000"/>
-              </a:lnSpc>
-              <a:spcBef>
-                <a:spcPts val="500"/>
-              </a:spcBef>
-              <a:buClr>
-                <a:schemeClr val="bg1"/>
-              </a:buClr>
-              <a:buSzPct val="75000"/>
-              <a:buFont typeface="+mj-lt"/>
-              <a:buAutoNum type="arabicPeriod"/>
-              <a:defRPr sz="1800" kern="1200">
-                <a:solidFill>
-                  <a:srgbClr val="FFFFFF"/>
-                </a:solidFill>
-                <a:latin typeface="+mn-lt"/>
-                <a:ea typeface="+mn-ea"/>
-                <a:cs typeface="+mn-cs"/>
-              </a:defRPr>
-            </a:lvl4pPr>
-            <a:lvl5pPr marL="228600" indent="-228600" algn="l" defTabSz="914400" rtl="0" eaLnBrk="1" latinLnBrk="0" hangingPunct="1">
-              <a:lnSpc>
-                <a:spcPct val="110000"/>
-              </a:lnSpc>
-              <a:spcBef>
-                <a:spcPts val="500"/>
-              </a:spcBef>
-              <a:buClr>
-                <a:schemeClr val="bg1"/>
-              </a:buClr>
-              <a:buSzPct val="75000"/>
-              <a:buFont typeface="+mj-lt"/>
-              <a:buAutoNum type="arabicPeriod"/>
-              <a:defRPr sz="1800" kern="1200">
-                <a:solidFill>
-                  <a:srgbClr val="FFFFFF"/>
-                </a:solidFill>
-                <a:latin typeface="+mn-lt"/>
-                <a:ea typeface="+mn-ea"/>
-                <a:cs typeface="+mn-cs"/>
-              </a:defRPr>
-            </a:lvl5pPr>
-            <a:lvl6pPr marL="2514600" indent="-228600" algn="l" defTabSz="914400" rtl="0" eaLnBrk="1" latinLnBrk="0" hangingPunct="1">
-              <a:lnSpc>
-                <a:spcPct val="90000"/>
-              </a:lnSpc>
-              <a:spcBef>
-                <a:spcPts val="500"/>
-              </a:spcBef>
-              <a:buFont typeface="Arial" panose="020B0604020202020204" pitchFamily="34" charset="0"/>
-              <a:buChar char="•"/>
-              <a:defRPr sz="1800" kern="1200">
-                <a:solidFill>
-                  <a:schemeClr val="tx1"/>
-                </a:solidFill>
-                <a:latin typeface="+mn-lt"/>
-                <a:ea typeface="+mn-ea"/>
-                <a:cs typeface="+mn-cs"/>
-              </a:defRPr>
-            </a:lvl6pPr>
-            <a:lvl7pPr marL="2971800" indent="-228600" algn="l" defTabSz="914400" rtl="0" eaLnBrk="1" latinLnBrk="0" hangingPunct="1">
-              <a:lnSpc>
-                <a:spcPct val="90000"/>
-              </a:lnSpc>
-              <a:spcBef>
-                <a:spcPts val="500"/>
-              </a:spcBef>
-              <a:buFont typeface="Arial" panose="020B0604020202020204" pitchFamily="34" charset="0"/>
-              <a:buChar char="•"/>
-              <a:defRPr sz="1800" kern="1200">
-                <a:solidFill>
-                  <a:schemeClr val="tx1"/>
-                </a:solidFill>
-                <a:latin typeface="+mn-lt"/>
-                <a:ea typeface="+mn-ea"/>
-                <a:cs typeface="+mn-cs"/>
-              </a:defRPr>
-            </a:lvl7pPr>
-            <a:lvl8pPr marL="3429000" indent="-228600" algn="l" defTabSz="914400" rtl="0" eaLnBrk="1" latinLnBrk="0" hangingPunct="1">
-              <a:lnSpc>
-                <a:spcPct val="90000"/>
-              </a:lnSpc>
-              <a:spcBef>
-                <a:spcPts val="500"/>
-              </a:spcBef>
-              <a:buFont typeface="Arial" panose="020B0604020202020204" pitchFamily="34" charset="0"/>
-              <a:buChar char="•"/>
-              <a:defRPr sz="1800" kern="1200">
-                <a:solidFill>
-                  <a:schemeClr val="tx1"/>
-                </a:solidFill>
-                <a:latin typeface="+mn-lt"/>
-                <a:ea typeface="+mn-ea"/>
-                <a:cs typeface="+mn-cs"/>
-              </a:defRPr>
-            </a:lvl8pPr>
-            <a:lvl9pPr marL="3886200" indent="-228600" algn="l" defTabSz="914400" rtl="0" eaLnBrk="1" latinLnBrk="0" hangingPunct="1">
-              <a:lnSpc>
-                <a:spcPct val="90000"/>
-              </a:lnSpc>
-              <a:spcBef>
-                <a:spcPts val="500"/>
-              </a:spcBef>
-              <a:buFont typeface="Arial" panose="020B0604020202020204" pitchFamily="34" charset="0"/>
-              <a:buChar char="•"/>
-              <a:defRPr sz="1800" kern="1200">
-                <a:solidFill>
-                  <a:schemeClr val="tx1"/>
-                </a:solidFill>
-                <a:latin typeface="+mn-lt"/>
-                <a:ea typeface="+mn-ea"/>
-                <a:cs typeface="+mn-cs"/>
-              </a:defRPr>
-            </a:lvl9pPr>
-          </a:lstStyle>
-          <a:p>
-            <a:r>
-              <a:rPr lang="fr-FR" dirty="0">
-                <a:solidFill>
-                  <a:schemeClr val="tx1"/>
-                </a:solidFill>
-              </a:rPr>
-              <a:t>Av</a:t>
-            </a:r>
-          </a:p>
-        </p:txBody>
-      </p:sp>
-      <p:sp>
-        <p:nvSpPr>
           <p:cNvPr id="11" name="Espace réservé du contenu 11">
             <a:extLst>
               <a:ext uri="{FF2B5EF4-FFF2-40B4-BE49-F238E27FC236}">
@@ -28354,6 +28237,289 @@
           </a:p>
         </p:txBody>
       </p:sp>
+      <p:sp>
+        <p:nvSpPr>
+          <p:cNvPr id="2" name="Espace réservé du contenu 11">
+            <a:extLst>
+              <a:ext uri="{FF2B5EF4-FFF2-40B4-BE49-F238E27FC236}">
+                <a16:creationId xmlns:a16="http://schemas.microsoft.com/office/drawing/2014/main" id="{6D542CC5-94E2-4C6E-6844-F6D63D7ED5E5}"/>
+              </a:ext>
+            </a:extLst>
+          </p:cNvPr>
+          <p:cNvSpPr txBox="1">
+            <a:spLocks/>
+          </p:cNvSpPr>
+          <p:nvPr/>
+        </p:nvSpPr>
+        <p:spPr>
+          <a:xfrm>
+            <a:off x="552476" y="1915446"/>
+            <a:ext cx="7382156" cy="4217087"/>
+          </a:xfrm>
+          <a:prstGeom prst="rect">
+            <a:avLst/>
+          </a:prstGeom>
+        </p:spPr>
+        <p:txBody>
+          <a:bodyPr rtlCol="0">
+            <a:noAutofit/>
+          </a:bodyPr>
+          <a:lstStyle>
+            <a:lvl1pPr marL="228600" indent="-228600" algn="l" defTabSz="914400" rtl="0" eaLnBrk="1" latinLnBrk="0" hangingPunct="1">
+              <a:lnSpc>
+                <a:spcPct val="110000"/>
+              </a:lnSpc>
+              <a:spcBef>
+                <a:spcPts val="1000"/>
+              </a:spcBef>
+              <a:buClr>
+                <a:schemeClr val="bg1"/>
+              </a:buClr>
+              <a:buSzPct val="75000"/>
+              <a:buFont typeface="+mj-lt"/>
+              <a:buAutoNum type="arabicPeriod"/>
+              <a:defRPr sz="2800" kern="1200">
+                <a:solidFill>
+                  <a:srgbClr val="FFFFFF"/>
+                </a:solidFill>
+                <a:latin typeface="+mn-lt"/>
+                <a:ea typeface="+mn-ea"/>
+                <a:cs typeface="+mn-cs"/>
+              </a:defRPr>
+            </a:lvl1pPr>
+            <a:lvl2pPr marL="228600" indent="-228600" algn="l" defTabSz="914400" rtl="0" eaLnBrk="1" latinLnBrk="0" hangingPunct="1">
+              <a:lnSpc>
+                <a:spcPct val="110000"/>
+              </a:lnSpc>
+              <a:spcBef>
+                <a:spcPts val="500"/>
+              </a:spcBef>
+              <a:buClr>
+                <a:schemeClr val="bg1"/>
+              </a:buClr>
+              <a:buSzPct val="75000"/>
+              <a:buFont typeface="+mj-lt"/>
+              <a:buAutoNum type="arabicPeriod"/>
+              <a:defRPr sz="2400" kern="1200">
+                <a:solidFill>
+                  <a:srgbClr val="FFFFFF"/>
+                </a:solidFill>
+                <a:latin typeface="+mn-lt"/>
+                <a:ea typeface="+mn-ea"/>
+                <a:cs typeface="+mn-cs"/>
+              </a:defRPr>
+            </a:lvl2pPr>
+            <a:lvl3pPr marL="228600" indent="-228600" algn="l" defTabSz="914400" rtl="0" eaLnBrk="1" latinLnBrk="0" hangingPunct="1">
+              <a:lnSpc>
+                <a:spcPct val="110000"/>
+              </a:lnSpc>
+              <a:spcBef>
+                <a:spcPts val="500"/>
+              </a:spcBef>
+              <a:buClr>
+                <a:schemeClr val="bg1"/>
+              </a:buClr>
+              <a:buSzPct val="75000"/>
+              <a:buFont typeface="+mj-lt"/>
+              <a:buAutoNum type="arabicPeriod"/>
+              <a:defRPr sz="2000" kern="1200">
+                <a:solidFill>
+                  <a:srgbClr val="FFFFFF"/>
+                </a:solidFill>
+                <a:latin typeface="+mn-lt"/>
+                <a:ea typeface="+mn-ea"/>
+                <a:cs typeface="+mn-cs"/>
+              </a:defRPr>
+            </a:lvl3pPr>
+            <a:lvl4pPr marL="228600" indent="-228600" algn="l" defTabSz="914400" rtl="0" eaLnBrk="1" latinLnBrk="0" hangingPunct="1">
+              <a:lnSpc>
+                <a:spcPct val="110000"/>
+              </a:lnSpc>
+              <a:spcBef>
+                <a:spcPts val="500"/>
+              </a:spcBef>
+              <a:buClr>
+                <a:schemeClr val="bg1"/>
+              </a:buClr>
+              <a:buSzPct val="75000"/>
+              <a:buFont typeface="+mj-lt"/>
+              <a:buAutoNum type="arabicPeriod"/>
+              <a:defRPr sz="1800" kern="1200">
+                <a:solidFill>
+                  <a:srgbClr val="FFFFFF"/>
+                </a:solidFill>
+                <a:latin typeface="+mn-lt"/>
+                <a:ea typeface="+mn-ea"/>
+                <a:cs typeface="+mn-cs"/>
+              </a:defRPr>
+            </a:lvl4pPr>
+            <a:lvl5pPr marL="228600" indent="-228600" algn="l" defTabSz="914400" rtl="0" eaLnBrk="1" latinLnBrk="0" hangingPunct="1">
+              <a:lnSpc>
+                <a:spcPct val="110000"/>
+              </a:lnSpc>
+              <a:spcBef>
+                <a:spcPts val="500"/>
+              </a:spcBef>
+              <a:buClr>
+                <a:schemeClr val="bg1"/>
+              </a:buClr>
+              <a:buSzPct val="75000"/>
+              <a:buFont typeface="+mj-lt"/>
+              <a:buAutoNum type="arabicPeriod"/>
+              <a:defRPr sz="1800" kern="1200">
+                <a:solidFill>
+                  <a:srgbClr val="FFFFFF"/>
+                </a:solidFill>
+                <a:latin typeface="+mn-lt"/>
+                <a:ea typeface="+mn-ea"/>
+                <a:cs typeface="+mn-cs"/>
+              </a:defRPr>
+            </a:lvl5pPr>
+            <a:lvl6pPr marL="2514600" indent="-228600" algn="l" defTabSz="914400" rtl="0" eaLnBrk="1" latinLnBrk="0" hangingPunct="1">
+              <a:lnSpc>
+                <a:spcPct val="90000"/>
+              </a:lnSpc>
+              <a:spcBef>
+                <a:spcPts val="500"/>
+              </a:spcBef>
+              <a:buFont typeface="Arial" panose="020B0604020202020204" pitchFamily="34" charset="0"/>
+              <a:buChar char="•"/>
+              <a:defRPr sz="1800" kern="1200">
+                <a:solidFill>
+                  <a:schemeClr val="tx1"/>
+                </a:solidFill>
+                <a:latin typeface="+mn-lt"/>
+                <a:ea typeface="+mn-ea"/>
+                <a:cs typeface="+mn-cs"/>
+              </a:defRPr>
+            </a:lvl6pPr>
+            <a:lvl7pPr marL="2971800" indent="-228600" algn="l" defTabSz="914400" rtl="0" eaLnBrk="1" latinLnBrk="0" hangingPunct="1">
+              <a:lnSpc>
+                <a:spcPct val="90000"/>
+              </a:lnSpc>
+              <a:spcBef>
+                <a:spcPts val="500"/>
+              </a:spcBef>
+              <a:buFont typeface="Arial" panose="020B0604020202020204" pitchFamily="34" charset="0"/>
+              <a:buChar char="•"/>
+              <a:defRPr sz="1800" kern="1200">
+                <a:solidFill>
+                  <a:schemeClr val="tx1"/>
+                </a:solidFill>
+                <a:latin typeface="+mn-lt"/>
+                <a:ea typeface="+mn-ea"/>
+                <a:cs typeface="+mn-cs"/>
+              </a:defRPr>
+            </a:lvl7pPr>
+            <a:lvl8pPr marL="3429000" indent="-228600" algn="l" defTabSz="914400" rtl="0" eaLnBrk="1" latinLnBrk="0" hangingPunct="1">
+              <a:lnSpc>
+                <a:spcPct val="90000"/>
+              </a:lnSpc>
+              <a:spcBef>
+                <a:spcPts val="500"/>
+              </a:spcBef>
+              <a:buFont typeface="Arial" panose="020B0604020202020204" pitchFamily="34" charset="0"/>
+              <a:buChar char="•"/>
+              <a:defRPr sz="1800" kern="1200">
+                <a:solidFill>
+                  <a:schemeClr val="tx1"/>
+                </a:solidFill>
+                <a:latin typeface="+mn-lt"/>
+                <a:ea typeface="+mn-ea"/>
+                <a:cs typeface="+mn-cs"/>
+              </a:defRPr>
+            </a:lvl8pPr>
+            <a:lvl9pPr marL="3886200" indent="-228600" algn="l" defTabSz="914400" rtl="0" eaLnBrk="1" latinLnBrk="0" hangingPunct="1">
+              <a:lnSpc>
+                <a:spcPct val="90000"/>
+              </a:lnSpc>
+              <a:spcBef>
+                <a:spcPts val="500"/>
+              </a:spcBef>
+              <a:buFont typeface="Arial" panose="020B0604020202020204" pitchFamily="34" charset="0"/>
+              <a:buChar char="•"/>
+              <a:defRPr sz="1800" kern="1200">
+                <a:solidFill>
+                  <a:schemeClr val="tx1"/>
+                </a:solidFill>
+                <a:latin typeface="+mn-lt"/>
+                <a:ea typeface="+mn-ea"/>
+                <a:cs typeface="+mn-cs"/>
+              </a:defRPr>
+            </a:lvl9pPr>
+          </a:lstStyle>
+          <a:p>
+            <a:r>
+              <a:rPr lang="fr-FR" sz="2200" dirty="0">
+                <a:solidFill>
+                  <a:schemeClr val="tx1"/>
+                </a:solidFill>
+              </a:rPr>
+              <a:t>• Dans le cadre de mes études, j’ai intégré l’entreprise Chauffage Der Energies pour un stage de 4 mois afin d’y appliquer mes connaissances.</a:t>
+            </a:r>
+          </a:p>
+          <a:p>
+            <a:r>
+              <a:rPr lang="fr-FR" sz="2200" dirty="0">
+                <a:solidFill>
+                  <a:schemeClr val="tx1"/>
+                </a:solidFill>
+              </a:rPr>
+              <a:t>• L’entreprise est spécialisée dans la proposition et l’installation de solution thermiques et climatiques dans lequel se présente un défi commercial :</a:t>
+            </a:r>
+          </a:p>
+          <a:p>
+            <a:r>
+              <a:rPr lang="fr-FR" sz="2200" i="1" dirty="0">
+                <a:solidFill>
+                  <a:schemeClr val="tx1"/>
+                </a:solidFill>
+              </a:rPr>
+              <a:t>    • La projection du client de l’installation souhaiter.</a:t>
+            </a:r>
+          </a:p>
+          <a:p>
+            <a:r>
+              <a:rPr lang="fr-FR" sz="2200" dirty="0">
+                <a:solidFill>
+                  <a:schemeClr val="tx1"/>
+                </a:solidFill>
+              </a:rPr>
+              <a:t>• Pour palier à ça, l’entreprise m’a offert comme mission de développer une application d’incrustation réaliste d’équipement thermique et climatique.</a:t>
+            </a:r>
+          </a:p>
+        </p:txBody>
+      </p:sp>
+      <p:pic>
+        <p:nvPicPr>
+          <p:cNvPr id="4" name="Image 3" descr="Technicien - Icônes utilisateur gratuites">
+            <a:extLst>
+              <a:ext uri="{FF2B5EF4-FFF2-40B4-BE49-F238E27FC236}">
+                <a16:creationId xmlns:a16="http://schemas.microsoft.com/office/drawing/2014/main" id="{EFC69CB3-F776-C828-E01C-88BDCD626869}"/>
+              </a:ext>
+            </a:extLst>
+          </p:cNvPr>
+          <p:cNvPicPr>
+            <a:picLocks noChangeAspect="1"/>
+          </p:cNvPicPr>
+          <p:nvPr/>
+        </p:nvPicPr>
+        <p:blipFill>
+          <a:blip r:embed="rId2"/>
+          <a:stretch>
+            <a:fillRect/>
+          </a:stretch>
+        </p:blipFill>
+        <p:spPr>
+          <a:xfrm>
+            <a:off x="8296843" y="2368574"/>
+            <a:ext cx="3106689" cy="3106689"/>
+          </a:xfrm>
+          <a:prstGeom prst="rect">
+            <a:avLst/>
+          </a:prstGeom>
+        </p:spPr>
+      </p:pic>
     </p:spTree>
     <p:extLst>
       <p:ext uri="{BB962C8B-B14F-4D97-AF65-F5344CB8AC3E}">
@@ -28368,6 +28534,625 @@
 </file>
 
 <file path=ppt/slides/slide5.xml><?xml version="1.0" encoding="utf-8"?>
+<p:sld xmlns:a="http://schemas.openxmlformats.org/drawingml/2006/main" xmlns:r="http://schemas.openxmlformats.org/officeDocument/2006/relationships" xmlns:p="http://schemas.openxmlformats.org/presentationml/2006/main">
+  <p:cSld>
+    <p:spTree>
+      <p:nvGrpSpPr>
+        <p:cNvPr id="1" name="">
+          <a:extLst>
+            <a:ext uri="{FF2B5EF4-FFF2-40B4-BE49-F238E27FC236}">
+              <a16:creationId xmlns:a16="http://schemas.microsoft.com/office/drawing/2014/main" id="{F124A143-BA2D-2968-277C-5423CAFBFDBC}"/>
+            </a:ext>
+          </a:extLst>
+        </p:cNvPr>
+        <p:cNvGrpSpPr/>
+        <p:nvPr/>
+      </p:nvGrpSpPr>
+      <p:grpSpPr>
+        <a:xfrm>
+          <a:off x="0" y="0"/>
+          <a:ext cx="0" cy="0"/>
+          <a:chOff x="0" y="0"/>
+          <a:chExt cx="0" cy="0"/>
+        </a:xfrm>
+      </p:grpSpPr>
+      <p:sp>
+        <p:nvSpPr>
+          <p:cNvPr id="3" name="Titre 2">
+            <a:extLst>
+              <a:ext uri="{FF2B5EF4-FFF2-40B4-BE49-F238E27FC236}">
+                <a16:creationId xmlns:a16="http://schemas.microsoft.com/office/drawing/2014/main" id="{D3212272-284E-5ADA-0413-ECE4A9B88EE4}"/>
+              </a:ext>
+            </a:extLst>
+          </p:cNvPr>
+          <p:cNvSpPr>
+            <a:spLocks noGrp="1"/>
+          </p:cNvSpPr>
+          <p:nvPr>
+            <p:ph type="ctrTitle"/>
+          </p:nvPr>
+        </p:nvSpPr>
+        <p:spPr>
+          <a:xfrm>
+            <a:off x="-157316" y="-79855"/>
+            <a:ext cx="12506632" cy="1603855"/>
+          </a:xfrm>
+          <a:solidFill>
+            <a:schemeClr val="tx2">
+              <a:lumMod val="50000"/>
+              <a:lumOff val="50000"/>
+              <a:alpha val="60000"/>
+            </a:schemeClr>
+          </a:solidFill>
+        </p:spPr>
+        <p:txBody>
+          <a:bodyPr/>
+          <a:lstStyle/>
+          <a:p>
+            <a:br>
+              <a:rPr lang="fr-FR" dirty="0"/>
+            </a:br>
+            <a:endParaRPr lang="fr-FR" dirty="0"/>
+          </a:p>
+        </p:txBody>
+      </p:sp>
+      <p:sp>
+        <p:nvSpPr>
+          <p:cNvPr id="5" name="Espace réservé de la date 4">
+            <a:extLst>
+              <a:ext uri="{FF2B5EF4-FFF2-40B4-BE49-F238E27FC236}">
+                <a16:creationId xmlns:a16="http://schemas.microsoft.com/office/drawing/2014/main" id="{4A062817-3F50-E9C5-5BD4-4434CAABBD42}"/>
+              </a:ext>
+            </a:extLst>
+          </p:cNvPr>
+          <p:cNvSpPr>
+            <a:spLocks noGrp="1"/>
+          </p:cNvSpPr>
+          <p:nvPr>
+            <p:ph type="dt" sz="half" idx="10"/>
+          </p:nvPr>
+        </p:nvSpPr>
+        <p:spPr/>
+        <p:txBody>
+          <a:bodyPr/>
+          <a:lstStyle/>
+          <a:p>
+            <a:r>
+              <a:rPr lang="fr-FR" dirty="0"/>
+              <a:t>Soitel Rémi</a:t>
+            </a:r>
+          </a:p>
+        </p:txBody>
+      </p:sp>
+      <p:sp>
+        <p:nvSpPr>
+          <p:cNvPr id="6" name="Espace réservé du pied de page 5">
+            <a:extLst>
+              <a:ext uri="{FF2B5EF4-FFF2-40B4-BE49-F238E27FC236}">
+                <a16:creationId xmlns:a16="http://schemas.microsoft.com/office/drawing/2014/main" id="{1A09DABC-C9F2-41DA-CA13-9327D93C3EB3}"/>
+              </a:ext>
+            </a:extLst>
+          </p:cNvPr>
+          <p:cNvSpPr>
+            <a:spLocks noGrp="1"/>
+          </p:cNvSpPr>
+          <p:nvPr>
+            <p:ph type="ftr" sz="quarter" idx="11"/>
+          </p:nvPr>
+        </p:nvSpPr>
+        <p:spPr/>
+        <p:txBody>
+          <a:bodyPr/>
+          <a:lstStyle/>
+          <a:p>
+            <a:r>
+              <a:rPr lang="fr-FR" dirty="0"/>
+              <a:t>Stage M2 en Entreprise</a:t>
+            </a:r>
+          </a:p>
+        </p:txBody>
+      </p:sp>
+      <p:sp>
+        <p:nvSpPr>
+          <p:cNvPr id="7" name="Espace réservé du numéro de diapositive 6">
+            <a:extLst>
+              <a:ext uri="{FF2B5EF4-FFF2-40B4-BE49-F238E27FC236}">
+                <a16:creationId xmlns:a16="http://schemas.microsoft.com/office/drawing/2014/main" id="{F790CC12-BFBE-7B33-ED12-8FC4903250EE}"/>
+              </a:ext>
+            </a:extLst>
+          </p:cNvPr>
+          <p:cNvSpPr>
+            <a:spLocks noGrp="1"/>
+          </p:cNvSpPr>
+          <p:nvPr>
+            <p:ph type="sldNum" sz="quarter" idx="12"/>
+          </p:nvPr>
+        </p:nvSpPr>
+        <p:spPr/>
+        <p:txBody>
+          <a:bodyPr/>
+          <a:lstStyle/>
+          <a:p>
+            <a:pPr rtl="0"/>
+            <a:fld id="{11A71338-8BA2-4C79-A6C5-5A8E30081D0C}" type="slidenum">
+              <a:rPr lang="fr-FR" noProof="0" smtClean="0"/>
+              <a:pPr rtl="0"/>
+              <a:t>5</a:t>
+            </a:fld>
+            <a:endParaRPr lang="fr-FR" noProof="0"/>
+          </a:p>
+        </p:txBody>
+      </p:sp>
+      <p:sp>
+        <p:nvSpPr>
+          <p:cNvPr id="11" name="Espace réservé du contenu 11">
+            <a:extLst>
+              <a:ext uri="{FF2B5EF4-FFF2-40B4-BE49-F238E27FC236}">
+                <a16:creationId xmlns:a16="http://schemas.microsoft.com/office/drawing/2014/main" id="{F638C9D2-6277-3C3E-DF29-23F74622AE93}"/>
+              </a:ext>
+            </a:extLst>
+          </p:cNvPr>
+          <p:cNvSpPr txBox="1">
+            <a:spLocks/>
+          </p:cNvSpPr>
+          <p:nvPr/>
+        </p:nvSpPr>
+        <p:spPr>
+          <a:xfrm>
+            <a:off x="648726" y="358024"/>
+            <a:ext cx="11341157" cy="728096"/>
+          </a:xfrm>
+          <a:prstGeom prst="rect">
+            <a:avLst/>
+          </a:prstGeom>
+        </p:spPr>
+        <p:txBody>
+          <a:bodyPr rtlCol="0">
+            <a:noAutofit/>
+          </a:bodyPr>
+          <a:lstStyle>
+            <a:lvl1pPr marL="228600" indent="-228600" algn="l" defTabSz="914400" rtl="0" eaLnBrk="1" latinLnBrk="0" hangingPunct="1">
+              <a:lnSpc>
+                <a:spcPct val="110000"/>
+              </a:lnSpc>
+              <a:spcBef>
+                <a:spcPts val="1000"/>
+              </a:spcBef>
+              <a:buClr>
+                <a:schemeClr val="bg1"/>
+              </a:buClr>
+              <a:buSzPct val="75000"/>
+              <a:buFont typeface="+mj-lt"/>
+              <a:buAutoNum type="arabicPeriod"/>
+              <a:defRPr sz="2800" kern="1200">
+                <a:solidFill>
+                  <a:srgbClr val="FFFFFF"/>
+                </a:solidFill>
+                <a:latin typeface="+mn-lt"/>
+                <a:ea typeface="+mn-ea"/>
+                <a:cs typeface="+mn-cs"/>
+              </a:defRPr>
+            </a:lvl1pPr>
+            <a:lvl2pPr marL="228600" indent="-228600" algn="l" defTabSz="914400" rtl="0" eaLnBrk="1" latinLnBrk="0" hangingPunct="1">
+              <a:lnSpc>
+                <a:spcPct val="110000"/>
+              </a:lnSpc>
+              <a:spcBef>
+                <a:spcPts val="500"/>
+              </a:spcBef>
+              <a:buClr>
+                <a:schemeClr val="bg1"/>
+              </a:buClr>
+              <a:buSzPct val="75000"/>
+              <a:buFont typeface="+mj-lt"/>
+              <a:buAutoNum type="arabicPeriod"/>
+              <a:defRPr sz="2400" kern="1200">
+                <a:solidFill>
+                  <a:srgbClr val="FFFFFF"/>
+                </a:solidFill>
+                <a:latin typeface="+mn-lt"/>
+                <a:ea typeface="+mn-ea"/>
+                <a:cs typeface="+mn-cs"/>
+              </a:defRPr>
+            </a:lvl2pPr>
+            <a:lvl3pPr marL="228600" indent="-228600" algn="l" defTabSz="914400" rtl="0" eaLnBrk="1" latinLnBrk="0" hangingPunct="1">
+              <a:lnSpc>
+                <a:spcPct val="110000"/>
+              </a:lnSpc>
+              <a:spcBef>
+                <a:spcPts val="500"/>
+              </a:spcBef>
+              <a:buClr>
+                <a:schemeClr val="bg1"/>
+              </a:buClr>
+              <a:buSzPct val="75000"/>
+              <a:buFont typeface="+mj-lt"/>
+              <a:buAutoNum type="arabicPeriod"/>
+              <a:defRPr sz="2000" kern="1200">
+                <a:solidFill>
+                  <a:srgbClr val="FFFFFF"/>
+                </a:solidFill>
+                <a:latin typeface="+mn-lt"/>
+                <a:ea typeface="+mn-ea"/>
+                <a:cs typeface="+mn-cs"/>
+              </a:defRPr>
+            </a:lvl3pPr>
+            <a:lvl4pPr marL="228600" indent="-228600" algn="l" defTabSz="914400" rtl="0" eaLnBrk="1" latinLnBrk="0" hangingPunct="1">
+              <a:lnSpc>
+                <a:spcPct val="110000"/>
+              </a:lnSpc>
+              <a:spcBef>
+                <a:spcPts val="500"/>
+              </a:spcBef>
+              <a:buClr>
+                <a:schemeClr val="bg1"/>
+              </a:buClr>
+              <a:buSzPct val="75000"/>
+              <a:buFont typeface="+mj-lt"/>
+              <a:buAutoNum type="arabicPeriod"/>
+              <a:defRPr sz="1800" kern="1200">
+                <a:solidFill>
+                  <a:srgbClr val="FFFFFF"/>
+                </a:solidFill>
+                <a:latin typeface="+mn-lt"/>
+                <a:ea typeface="+mn-ea"/>
+                <a:cs typeface="+mn-cs"/>
+              </a:defRPr>
+            </a:lvl4pPr>
+            <a:lvl5pPr marL="228600" indent="-228600" algn="l" defTabSz="914400" rtl="0" eaLnBrk="1" latinLnBrk="0" hangingPunct="1">
+              <a:lnSpc>
+                <a:spcPct val="110000"/>
+              </a:lnSpc>
+              <a:spcBef>
+                <a:spcPts val="500"/>
+              </a:spcBef>
+              <a:buClr>
+                <a:schemeClr val="bg1"/>
+              </a:buClr>
+              <a:buSzPct val="75000"/>
+              <a:buFont typeface="+mj-lt"/>
+              <a:buAutoNum type="arabicPeriod"/>
+              <a:defRPr sz="1800" kern="1200">
+                <a:solidFill>
+                  <a:srgbClr val="FFFFFF"/>
+                </a:solidFill>
+                <a:latin typeface="+mn-lt"/>
+                <a:ea typeface="+mn-ea"/>
+                <a:cs typeface="+mn-cs"/>
+              </a:defRPr>
+            </a:lvl5pPr>
+            <a:lvl6pPr marL="2514600" indent="-228600" algn="l" defTabSz="914400" rtl="0" eaLnBrk="1" latinLnBrk="0" hangingPunct="1">
+              <a:lnSpc>
+                <a:spcPct val="90000"/>
+              </a:lnSpc>
+              <a:spcBef>
+                <a:spcPts val="500"/>
+              </a:spcBef>
+              <a:buFont typeface="Arial" panose="020B0604020202020204" pitchFamily="34" charset="0"/>
+              <a:buChar char="•"/>
+              <a:defRPr sz="1800" kern="1200">
+                <a:solidFill>
+                  <a:schemeClr val="tx1"/>
+                </a:solidFill>
+                <a:latin typeface="+mn-lt"/>
+                <a:ea typeface="+mn-ea"/>
+                <a:cs typeface="+mn-cs"/>
+              </a:defRPr>
+            </a:lvl6pPr>
+            <a:lvl7pPr marL="2971800" indent="-228600" algn="l" defTabSz="914400" rtl="0" eaLnBrk="1" latinLnBrk="0" hangingPunct="1">
+              <a:lnSpc>
+                <a:spcPct val="90000"/>
+              </a:lnSpc>
+              <a:spcBef>
+                <a:spcPts val="500"/>
+              </a:spcBef>
+              <a:buFont typeface="Arial" panose="020B0604020202020204" pitchFamily="34" charset="0"/>
+              <a:buChar char="•"/>
+              <a:defRPr sz="1800" kern="1200">
+                <a:solidFill>
+                  <a:schemeClr val="tx1"/>
+                </a:solidFill>
+                <a:latin typeface="+mn-lt"/>
+                <a:ea typeface="+mn-ea"/>
+                <a:cs typeface="+mn-cs"/>
+              </a:defRPr>
+            </a:lvl7pPr>
+            <a:lvl8pPr marL="3429000" indent="-228600" algn="l" defTabSz="914400" rtl="0" eaLnBrk="1" latinLnBrk="0" hangingPunct="1">
+              <a:lnSpc>
+                <a:spcPct val="90000"/>
+              </a:lnSpc>
+              <a:spcBef>
+                <a:spcPts val="500"/>
+              </a:spcBef>
+              <a:buFont typeface="Arial" panose="020B0604020202020204" pitchFamily="34" charset="0"/>
+              <a:buChar char="•"/>
+              <a:defRPr sz="1800" kern="1200">
+                <a:solidFill>
+                  <a:schemeClr val="tx1"/>
+                </a:solidFill>
+                <a:latin typeface="+mn-lt"/>
+                <a:ea typeface="+mn-ea"/>
+                <a:cs typeface="+mn-cs"/>
+              </a:defRPr>
+            </a:lvl8pPr>
+            <a:lvl9pPr marL="3886200" indent="-228600" algn="l" defTabSz="914400" rtl="0" eaLnBrk="1" latinLnBrk="0" hangingPunct="1">
+              <a:lnSpc>
+                <a:spcPct val="90000"/>
+              </a:lnSpc>
+              <a:spcBef>
+                <a:spcPts val="500"/>
+              </a:spcBef>
+              <a:buFont typeface="Arial" panose="020B0604020202020204" pitchFamily="34" charset="0"/>
+              <a:buChar char="•"/>
+              <a:defRPr sz="1800" kern="1200">
+                <a:solidFill>
+                  <a:schemeClr val="tx1"/>
+                </a:solidFill>
+                <a:latin typeface="+mn-lt"/>
+                <a:ea typeface="+mn-ea"/>
+                <a:cs typeface="+mn-cs"/>
+              </a:defRPr>
+            </a:lvl9pPr>
+          </a:lstStyle>
+          <a:p>
+            <a:pPr marL="0" indent="0">
+              <a:buNone/>
+            </a:pPr>
+            <a:r>
+              <a:rPr lang="fr-FR" sz="4400" dirty="0">
+                <a:solidFill>
+                  <a:schemeClr val="bg1"/>
+                </a:solidFill>
+                <a:latin typeface="Posterama" panose="020B0504020200020000" pitchFamily="34" charset="0"/>
+                <a:cs typeface="Posterama" panose="020B0504020200020000" pitchFamily="34" charset="0"/>
+              </a:rPr>
+              <a:t>Contexte et Objectif du Projet</a:t>
+            </a:r>
+          </a:p>
+        </p:txBody>
+      </p:sp>
+      <p:sp>
+        <p:nvSpPr>
+          <p:cNvPr id="2" name="Espace réservé du contenu 11">
+            <a:extLst>
+              <a:ext uri="{FF2B5EF4-FFF2-40B4-BE49-F238E27FC236}">
+                <a16:creationId xmlns:a16="http://schemas.microsoft.com/office/drawing/2014/main" id="{C29411BA-2143-2650-F5E0-5B6D42887C9E}"/>
+              </a:ext>
+            </a:extLst>
+          </p:cNvPr>
+          <p:cNvSpPr txBox="1">
+            <a:spLocks/>
+          </p:cNvSpPr>
+          <p:nvPr/>
+        </p:nvSpPr>
+        <p:spPr>
+          <a:xfrm>
+            <a:off x="552476" y="1915446"/>
+            <a:ext cx="7382156" cy="4217087"/>
+          </a:xfrm>
+          <a:prstGeom prst="rect">
+            <a:avLst/>
+          </a:prstGeom>
+        </p:spPr>
+        <p:txBody>
+          <a:bodyPr rtlCol="0">
+            <a:noAutofit/>
+          </a:bodyPr>
+          <a:lstStyle>
+            <a:lvl1pPr marL="228600" indent="-228600" algn="l" defTabSz="914400" rtl="0" eaLnBrk="1" latinLnBrk="0" hangingPunct="1">
+              <a:lnSpc>
+                <a:spcPct val="110000"/>
+              </a:lnSpc>
+              <a:spcBef>
+                <a:spcPts val="1000"/>
+              </a:spcBef>
+              <a:buClr>
+                <a:schemeClr val="bg1"/>
+              </a:buClr>
+              <a:buSzPct val="75000"/>
+              <a:buFont typeface="+mj-lt"/>
+              <a:buAutoNum type="arabicPeriod"/>
+              <a:defRPr sz="2800" kern="1200">
+                <a:solidFill>
+                  <a:srgbClr val="FFFFFF"/>
+                </a:solidFill>
+                <a:latin typeface="+mn-lt"/>
+                <a:ea typeface="+mn-ea"/>
+                <a:cs typeface="+mn-cs"/>
+              </a:defRPr>
+            </a:lvl1pPr>
+            <a:lvl2pPr marL="228600" indent="-228600" algn="l" defTabSz="914400" rtl="0" eaLnBrk="1" latinLnBrk="0" hangingPunct="1">
+              <a:lnSpc>
+                <a:spcPct val="110000"/>
+              </a:lnSpc>
+              <a:spcBef>
+                <a:spcPts val="500"/>
+              </a:spcBef>
+              <a:buClr>
+                <a:schemeClr val="bg1"/>
+              </a:buClr>
+              <a:buSzPct val="75000"/>
+              <a:buFont typeface="+mj-lt"/>
+              <a:buAutoNum type="arabicPeriod"/>
+              <a:defRPr sz="2400" kern="1200">
+                <a:solidFill>
+                  <a:srgbClr val="FFFFFF"/>
+                </a:solidFill>
+                <a:latin typeface="+mn-lt"/>
+                <a:ea typeface="+mn-ea"/>
+                <a:cs typeface="+mn-cs"/>
+              </a:defRPr>
+            </a:lvl2pPr>
+            <a:lvl3pPr marL="228600" indent="-228600" algn="l" defTabSz="914400" rtl="0" eaLnBrk="1" latinLnBrk="0" hangingPunct="1">
+              <a:lnSpc>
+                <a:spcPct val="110000"/>
+              </a:lnSpc>
+              <a:spcBef>
+                <a:spcPts val="500"/>
+              </a:spcBef>
+              <a:buClr>
+                <a:schemeClr val="bg1"/>
+              </a:buClr>
+              <a:buSzPct val="75000"/>
+              <a:buFont typeface="+mj-lt"/>
+              <a:buAutoNum type="arabicPeriod"/>
+              <a:defRPr sz="2000" kern="1200">
+                <a:solidFill>
+                  <a:srgbClr val="FFFFFF"/>
+                </a:solidFill>
+                <a:latin typeface="+mn-lt"/>
+                <a:ea typeface="+mn-ea"/>
+                <a:cs typeface="+mn-cs"/>
+              </a:defRPr>
+            </a:lvl3pPr>
+            <a:lvl4pPr marL="228600" indent="-228600" algn="l" defTabSz="914400" rtl="0" eaLnBrk="1" latinLnBrk="0" hangingPunct="1">
+              <a:lnSpc>
+                <a:spcPct val="110000"/>
+              </a:lnSpc>
+              <a:spcBef>
+                <a:spcPts val="500"/>
+              </a:spcBef>
+              <a:buClr>
+                <a:schemeClr val="bg1"/>
+              </a:buClr>
+              <a:buSzPct val="75000"/>
+              <a:buFont typeface="+mj-lt"/>
+              <a:buAutoNum type="arabicPeriod"/>
+              <a:defRPr sz="1800" kern="1200">
+                <a:solidFill>
+                  <a:srgbClr val="FFFFFF"/>
+                </a:solidFill>
+                <a:latin typeface="+mn-lt"/>
+                <a:ea typeface="+mn-ea"/>
+                <a:cs typeface="+mn-cs"/>
+              </a:defRPr>
+            </a:lvl4pPr>
+            <a:lvl5pPr marL="228600" indent="-228600" algn="l" defTabSz="914400" rtl="0" eaLnBrk="1" latinLnBrk="0" hangingPunct="1">
+              <a:lnSpc>
+                <a:spcPct val="110000"/>
+              </a:lnSpc>
+              <a:spcBef>
+                <a:spcPts val="500"/>
+              </a:spcBef>
+              <a:buClr>
+                <a:schemeClr val="bg1"/>
+              </a:buClr>
+              <a:buSzPct val="75000"/>
+              <a:buFont typeface="+mj-lt"/>
+              <a:buAutoNum type="arabicPeriod"/>
+              <a:defRPr sz="1800" kern="1200">
+                <a:solidFill>
+                  <a:srgbClr val="FFFFFF"/>
+                </a:solidFill>
+                <a:latin typeface="+mn-lt"/>
+                <a:ea typeface="+mn-ea"/>
+                <a:cs typeface="+mn-cs"/>
+              </a:defRPr>
+            </a:lvl5pPr>
+            <a:lvl6pPr marL="2514600" indent="-228600" algn="l" defTabSz="914400" rtl="0" eaLnBrk="1" latinLnBrk="0" hangingPunct="1">
+              <a:lnSpc>
+                <a:spcPct val="90000"/>
+              </a:lnSpc>
+              <a:spcBef>
+                <a:spcPts val="500"/>
+              </a:spcBef>
+              <a:buFont typeface="Arial" panose="020B0604020202020204" pitchFamily="34" charset="0"/>
+              <a:buChar char="•"/>
+              <a:defRPr sz="1800" kern="1200">
+                <a:solidFill>
+                  <a:schemeClr val="tx1"/>
+                </a:solidFill>
+                <a:latin typeface="+mn-lt"/>
+                <a:ea typeface="+mn-ea"/>
+                <a:cs typeface="+mn-cs"/>
+              </a:defRPr>
+            </a:lvl6pPr>
+            <a:lvl7pPr marL="2971800" indent="-228600" algn="l" defTabSz="914400" rtl="0" eaLnBrk="1" latinLnBrk="0" hangingPunct="1">
+              <a:lnSpc>
+                <a:spcPct val="90000"/>
+              </a:lnSpc>
+              <a:spcBef>
+                <a:spcPts val="500"/>
+              </a:spcBef>
+              <a:buFont typeface="Arial" panose="020B0604020202020204" pitchFamily="34" charset="0"/>
+              <a:buChar char="•"/>
+              <a:defRPr sz="1800" kern="1200">
+                <a:solidFill>
+                  <a:schemeClr val="tx1"/>
+                </a:solidFill>
+                <a:latin typeface="+mn-lt"/>
+                <a:ea typeface="+mn-ea"/>
+                <a:cs typeface="+mn-cs"/>
+              </a:defRPr>
+            </a:lvl7pPr>
+            <a:lvl8pPr marL="3429000" indent="-228600" algn="l" defTabSz="914400" rtl="0" eaLnBrk="1" latinLnBrk="0" hangingPunct="1">
+              <a:lnSpc>
+                <a:spcPct val="90000"/>
+              </a:lnSpc>
+              <a:spcBef>
+                <a:spcPts val="500"/>
+              </a:spcBef>
+              <a:buFont typeface="Arial" panose="020B0604020202020204" pitchFamily="34" charset="0"/>
+              <a:buChar char="•"/>
+              <a:defRPr sz="1800" kern="1200">
+                <a:solidFill>
+                  <a:schemeClr val="tx1"/>
+                </a:solidFill>
+                <a:latin typeface="+mn-lt"/>
+                <a:ea typeface="+mn-ea"/>
+                <a:cs typeface="+mn-cs"/>
+              </a:defRPr>
+            </a:lvl8pPr>
+            <a:lvl9pPr marL="3886200" indent="-228600" algn="l" defTabSz="914400" rtl="0" eaLnBrk="1" latinLnBrk="0" hangingPunct="1">
+              <a:lnSpc>
+                <a:spcPct val="90000"/>
+              </a:lnSpc>
+              <a:spcBef>
+                <a:spcPts val="500"/>
+              </a:spcBef>
+              <a:buFont typeface="Arial" panose="020B0604020202020204" pitchFamily="34" charset="0"/>
+              <a:buChar char="•"/>
+              <a:defRPr sz="1800" kern="1200">
+                <a:solidFill>
+                  <a:schemeClr val="tx1"/>
+                </a:solidFill>
+                <a:latin typeface="+mn-lt"/>
+                <a:ea typeface="+mn-ea"/>
+                <a:cs typeface="+mn-cs"/>
+              </a:defRPr>
+            </a:lvl9pPr>
+          </a:lstStyle>
+          <a:p>
+            <a:r>
+              <a:rPr lang="fr-FR" sz="2200">
+                <a:solidFill>
+                  <a:schemeClr val="tx1"/>
+                </a:solidFill>
+              </a:rPr>
+              <a:t>• Dans</a:t>
+            </a:r>
+            <a:endParaRPr lang="fr-FR" sz="2200" dirty="0">
+              <a:solidFill>
+                <a:schemeClr val="tx1"/>
+              </a:solidFill>
+            </a:endParaRPr>
+          </a:p>
+        </p:txBody>
+      </p:sp>
+    </p:spTree>
+    <p:extLst>
+      <p:ext uri="{BB962C8B-B14F-4D97-AF65-F5344CB8AC3E}">
+        <p14:creationId xmlns:p14="http://schemas.microsoft.com/office/powerpoint/2010/main" val="1815961150"/>
+      </p:ext>
+    </p:extLst>
+  </p:cSld>
+  <p:clrMapOvr>
+    <a:masterClrMapping/>
+  </p:clrMapOvr>
+</p:sld>
+</file>
+
+<file path=ppt/slides/slide6.xml><?xml version="1.0" encoding="utf-8"?>
 <p:sld xmlns:a="http://schemas.openxmlformats.org/drawingml/2006/main" xmlns:r="http://schemas.openxmlformats.org/officeDocument/2006/relationships" xmlns:p="http://schemas.openxmlformats.org/presentationml/2006/main">
   <p:cSld>
     <p:spTree>
@@ -28514,7 +29299,7 @@
             <a:fld id="{11A71338-8BA2-4C79-A6C5-5A8E30081D0C}" type="slidenum">
               <a:rPr lang="fr-FR" smtClean="0"/>
               <a:pPr rtl="0"/>
-              <a:t>5</a:t>
+              <a:t>6</a:t>
             </a:fld>
             <a:endParaRPr lang="fr-FR" dirty="0"/>
           </a:p>
@@ -28564,7 +29349,7 @@
 </p:sld>
 </file>
 
-<file path=ppt/slides/slide6.xml><?xml version="1.0" encoding="utf-8"?>
+<file path=ppt/slides/slide7.xml><?xml version="1.0" encoding="utf-8"?>
 <p:sld xmlns:a="http://schemas.openxmlformats.org/drawingml/2006/main" xmlns:r="http://schemas.openxmlformats.org/officeDocument/2006/relationships" xmlns:p="http://schemas.openxmlformats.org/presentationml/2006/main">
   <p:cSld>
     <p:spTree>
@@ -28864,7 +29649,7 @@
             <a:fld id="{11A71338-8BA2-4C79-A6C5-5A8E30081D0C}" type="slidenum">
               <a:rPr lang="fr-FR" smtClean="0"/>
               <a:pPr rtl="0"/>
-              <a:t>6</a:t>
+              <a:t>7</a:t>
             </a:fld>
             <a:endParaRPr lang="fr-FR"/>
           </a:p>
@@ -28883,7 +29668,7 @@
 </p:sld>
 </file>
 
-<file path=ppt/slides/slide7.xml><?xml version="1.0" encoding="utf-8"?>
+<file path=ppt/slides/slide8.xml><?xml version="1.0" encoding="utf-8"?>
 <p:sld xmlns:a="http://schemas.openxmlformats.org/drawingml/2006/main" xmlns:r="http://schemas.openxmlformats.org/officeDocument/2006/relationships" xmlns:p="http://schemas.openxmlformats.org/presentationml/2006/main">
   <p:cSld>
     <p:spTree>
@@ -29258,7 +30043,7 @@
             <a:fld id="{11A71338-8BA2-4C79-A6C5-5A8E30081D0C}" type="slidenum">
               <a:rPr lang="fr-FR" smtClean="0"/>
               <a:pPr rtl="0"/>
-              <a:t>7</a:t>
+              <a:t>8</a:t>
             </a:fld>
             <a:endParaRPr lang="fr-FR"/>
           </a:p>
@@ -29277,7 +30062,7 @@
 </p:sld>
 </file>
 
-<file path=ppt/slides/slide8.xml><?xml version="1.0" encoding="utf-8"?>
+<file path=ppt/slides/slide9.xml><?xml version="1.0" encoding="utf-8"?>
 <p:sld xmlns:a="http://schemas.openxmlformats.org/drawingml/2006/main" xmlns:r="http://schemas.openxmlformats.org/officeDocument/2006/relationships" xmlns:p="http://schemas.openxmlformats.org/presentationml/2006/main">
   <p:cSld>
     <p:spTree>
@@ -29564,7 +30349,7 @@
             <a:fld id="{11A71338-8BA2-4C79-A6C5-5A8E30081D0C}" type="slidenum">
               <a:rPr lang="fr-FR" smtClean="0"/>
               <a:pPr rtl="0"/>
-              <a:t>8</a:t>
+              <a:t>9</a:t>
             </a:fld>
             <a:endParaRPr lang="fr-FR"/>
           </a:p>
@@ -29574,100 +30359,6 @@
     <p:extLst>
       <p:ext uri="{BB962C8B-B14F-4D97-AF65-F5344CB8AC3E}">
         <p14:creationId xmlns:p14="http://schemas.microsoft.com/office/powerpoint/2010/main" val="638530597"/>
-      </p:ext>
-    </p:extLst>
-  </p:cSld>
-  <p:clrMapOvr>
-    <a:masterClrMapping/>
-  </p:clrMapOvr>
-</p:sld>
-</file>
-
-<file path=ppt/slides/slide9.xml><?xml version="1.0" encoding="utf-8"?>
-<p:sld xmlns:a="http://schemas.openxmlformats.org/drawingml/2006/main" xmlns:r="http://schemas.openxmlformats.org/officeDocument/2006/relationships" xmlns:p="http://schemas.openxmlformats.org/presentationml/2006/main">
-  <p:cSld>
-    <p:spTree>
-      <p:nvGrpSpPr>
-        <p:cNvPr id="1" name=""/>
-        <p:cNvGrpSpPr/>
-        <p:nvPr/>
-      </p:nvGrpSpPr>
-      <p:grpSpPr>
-        <a:xfrm>
-          <a:off x="0" y="0"/>
-          <a:ext cx="0" cy="0"/>
-          <a:chOff x="0" y="0"/>
-          <a:chExt cx="0" cy="0"/>
-        </a:xfrm>
-      </p:grpSpPr>
-      <p:sp>
-        <p:nvSpPr>
-          <p:cNvPr id="54" name="Titre 53">
-            <a:extLst>
-              <a:ext uri="{FF2B5EF4-FFF2-40B4-BE49-F238E27FC236}">
-                <a16:creationId xmlns:a16="http://schemas.microsoft.com/office/drawing/2014/main" id="{DBE49DF2-C4C7-4EC0-BF95-00C033956ED5}"/>
-              </a:ext>
-            </a:extLst>
-          </p:cNvPr>
-          <p:cNvSpPr>
-            <a:spLocks noGrp="1"/>
-          </p:cNvSpPr>
-          <p:nvPr>
-            <p:ph type="title"/>
-          </p:nvPr>
-        </p:nvSpPr>
-        <p:spPr>
-          <a:xfrm>
-            <a:off x="531405" y="1643117"/>
-            <a:ext cx="5465225" cy="2637455"/>
-          </a:xfrm>
-        </p:spPr>
-        <p:txBody>
-          <a:bodyPr rtlCol="0"/>
-          <a:lstStyle/>
-          <a:p>
-            <a:pPr rtl="0"/>
-            <a:r>
-              <a:rPr lang="fr-FR" dirty="0"/>
-              <a:t>Merci de votre Attention</a:t>
-            </a:r>
-          </a:p>
-        </p:txBody>
-      </p:sp>
-      <p:pic>
-        <p:nvPicPr>
-          <p:cNvPr id="11" name="Image 10">
-            <a:extLst>
-              <a:ext uri="{FF2B5EF4-FFF2-40B4-BE49-F238E27FC236}">
-                <a16:creationId xmlns:a16="http://schemas.microsoft.com/office/drawing/2014/main" id="{C6CD20B5-B984-747C-4C89-72C2D1380677}"/>
-              </a:ext>
-            </a:extLst>
-          </p:cNvPr>
-          <p:cNvPicPr>
-            <a:picLocks noChangeAspect="1"/>
-          </p:cNvPicPr>
-          <p:nvPr/>
-        </p:nvPicPr>
-        <p:blipFill>
-          <a:blip r:embed="rId3"/>
-          <a:stretch>
-            <a:fillRect/>
-          </a:stretch>
-        </p:blipFill>
-        <p:spPr>
-          <a:xfrm>
-            <a:off x="5204315" y="72485"/>
-            <a:ext cx="6713029" cy="6713029"/>
-          </a:xfrm>
-          <a:prstGeom prst="rect">
-            <a:avLst/>
-          </a:prstGeom>
-        </p:spPr>
-      </p:pic>
-    </p:spTree>
-    <p:extLst>
-      <p:ext uri="{BB962C8B-B14F-4D97-AF65-F5344CB8AC3E}">
-        <p14:creationId xmlns:p14="http://schemas.microsoft.com/office/powerpoint/2010/main" val="1833651384"/>
       </p:ext>
     </p:extLst>
   </p:cSld>

</xml_diff>